<commit_message>
Inclui tabela de resultados acumulados no quinto slide
</commit_message>
<xml_diff>
--- a/apresentacoes/Cenario_60_porcento.pptx
+++ b/apresentacoes/Cenario_60_porcento.pptx
@@ -9,6 +9,7 @@
     <p:sldId id="257" r:id="rId8"/>
     <p:sldId id="258" r:id="rId9"/>
     <p:sldId id="259" r:id="rId10"/>
+    <p:sldId id="260" r:id="rId11"/>
   </p:sldIdLst>
   <p:sldSz cx="12191695" cy="6858000" type="screen4x3"/>
   <p:notesSz cx="6858000" cy="9144000"/>
@@ -3328,7 +3329,7 @@
               </a:defRPr>
             </a:pPr>
             <a:r>
-              <a:t>1/4</a:t>
+              <a:t>1/5</a:t>
             </a:r>
           </a:p>
         </p:txBody>
@@ -4104,7 +4105,7 @@
               </a:defRPr>
             </a:pPr>
             <a:r>
-              <a:t>2/4</a:t>
+              <a:t>2/5</a:t>
             </a:r>
           </a:p>
         </p:txBody>
@@ -4887,7 +4888,7 @@
               </a:defRPr>
             </a:pPr>
             <a:r>
-              <a:t>3/4</a:t>
+              <a:t>3/5</a:t>
             </a:r>
           </a:p>
         </p:txBody>
@@ -5610,7 +5611,7 @@
               </a:defRPr>
             </a:pPr>
             <a:r>
-              <a:t>4/4</a:t>
+              <a:t>4/5</a:t>
             </a:r>
           </a:p>
         </p:txBody>
@@ -6068,6 +6069,901 @@
             </a:pPr>
             <a:r>
               <a:t>Estimativa bruta das novas coortes, sem dupla contagem; não representa a despesa total do estoque de aposentadorias.</a:t>
+            </a:r>
+          </a:p>
+        </p:txBody>
+      </p:sp>
+    </p:spTree>
+  </p:cSld>
+  <p:clrMapOvr>
+    <a:masterClrMapping/>
+  </p:clrMapOvr>
+</p:sld>
+</file>
+
+<file path=ppt/slides/slide5.xml><?xml version="1.0" encoding="utf-8"?>
+<p:sld xmlns:a="http://schemas.openxmlformats.org/drawingml/2006/main" xmlns:p="http://schemas.openxmlformats.org/presentationml/2006/main" xmlns:r="http://schemas.openxmlformats.org/officeDocument/2006/relationships">
+  <p:cSld>
+    <p:spTree>
+      <p:nvGrpSpPr>
+        <p:cNvPr id="1" name=""/>
+        <p:cNvGrpSpPr/>
+        <p:nvPr/>
+      </p:nvGrpSpPr>
+      <p:grpSpPr/>
+      <p:sp>
+        <p:nvSpPr>
+          <p:cNvPr id="2" name="Rectangle 1"/>
+          <p:cNvSpPr/>
+          <p:nvPr/>
+        </p:nvSpPr>
+        <p:spPr>
+          <a:xfrm>
+            <a:off x="0" y="0"/>
+            <a:ext cx="12191695" cy="109728"/>
+          </a:xfrm>
+          <a:prstGeom prst="rect">
+            <a:avLst/>
+          </a:prstGeom>
+          <a:solidFill>
+            <a:srgbClr val="008675"/>
+          </a:solidFill>
+          <a:ln>
+            <a:noFill/>
+          </a:ln>
+        </p:spPr>
+        <p:style>
+          <a:lnRef idx="1">
+            <a:schemeClr val="accent1"/>
+          </a:lnRef>
+          <a:fillRef idx="3">
+            <a:schemeClr val="accent1"/>
+          </a:fillRef>
+          <a:effectRef idx="2">
+            <a:schemeClr val="accent1"/>
+          </a:effectRef>
+          <a:fontRef idx="minor">
+            <a:schemeClr val="lt1"/>
+          </a:fontRef>
+        </p:style>
+        <p:txBody>
+          <a:bodyPr rtlCol="0" anchor="ctr"/>
+          <a:lstStyle/>
+          <a:p>
+            <a:pPr algn="ctr"/>
+          </a:p>
+        </p:txBody>
+      </p:sp>
+      <p:sp>
+        <p:nvSpPr>
+          <p:cNvPr id="3" name="TextBox 2"/>
+          <p:cNvSpPr txBox="1"/>
+          <p:nvPr/>
+        </p:nvSpPr>
+        <p:spPr>
+          <a:xfrm>
+            <a:off x="502920" y="320040"/>
+            <a:ext cx="10972800" cy="274320"/>
+          </a:xfrm>
+          <a:prstGeom prst="rect">
+            <a:avLst/>
+          </a:prstGeom>
+          <a:noFill/>
+        </p:spPr>
+        <p:txBody>
+          <a:bodyPr wrap="square" lIns="0" rIns="0" tIns="0" bIns="0">
+            <a:spAutoFit/>
+          </a:bodyPr>
+          <a:lstStyle/>
+          <a:p>
+            <a:pPr>
+              <a:spcAft>
+                <a:spcPts val="600"/>
+              </a:spcAft>
+              <a:defRPr sz="1100" b="1">
+                <a:solidFill>
+                  <a:srgbClr val="008675"/>
+                </a:solidFill>
+                <a:latin typeface="DejaVu Sans"/>
+              </a:defRPr>
+            </a:pPr>
+            <a:r>
+              <a:t>05 • RESULTADOS EM TABELA</a:t>
+            </a:r>
+          </a:p>
+        </p:txBody>
+      </p:sp>
+      <p:sp>
+        <p:nvSpPr>
+          <p:cNvPr id="4" name="TextBox 3"/>
+          <p:cNvSpPr txBox="1"/>
+          <p:nvPr/>
+        </p:nvSpPr>
+        <p:spPr>
+          <a:xfrm>
+            <a:off x="502920" y="786384"/>
+            <a:ext cx="11155680" cy="822960"/>
+          </a:xfrm>
+          <a:prstGeom prst="rect">
+            <a:avLst/>
+          </a:prstGeom>
+          <a:noFill/>
+        </p:spPr>
+        <p:txBody>
+          <a:bodyPr wrap="square" lIns="0" rIns="0" tIns="0" bIns="0">
+            <a:spAutoFit/>
+          </a:bodyPr>
+          <a:lstStyle/>
+          <a:p>
+            <a:pPr>
+              <a:spcAft>
+                <a:spcPts val="600"/>
+              </a:spcAft>
+              <a:defRPr sz="2900" b="1">
+                <a:solidFill>
+                  <a:srgbClr val="142D45"/>
+                </a:solidFill>
+                <a:latin typeface="DejaVu Sans"/>
+              </a:defRPr>
+            </a:pPr>
+            <a:r>
+              <a:t>Economia acumulada frente às regras atuais</a:t>
+            </a:r>
+          </a:p>
+        </p:txBody>
+      </p:sp>
+      <p:sp>
+        <p:nvSpPr>
+          <p:cNvPr id="5" name="Rectangle 4"/>
+          <p:cNvSpPr/>
+          <p:nvPr/>
+        </p:nvSpPr>
+        <p:spPr>
+          <a:xfrm>
+            <a:off x="502920" y="6345936"/>
+            <a:ext cx="11155680" cy="10972"/>
+          </a:xfrm>
+          <a:prstGeom prst="rect">
+            <a:avLst/>
+          </a:prstGeom>
+          <a:solidFill>
+            <a:srgbClr val="D9E3E7"/>
+          </a:solidFill>
+          <a:ln>
+            <a:noFill/>
+          </a:ln>
+        </p:spPr>
+        <p:style>
+          <a:lnRef idx="1">
+            <a:schemeClr val="accent1"/>
+          </a:lnRef>
+          <a:fillRef idx="3">
+            <a:schemeClr val="accent1"/>
+          </a:fillRef>
+          <a:effectRef idx="2">
+            <a:schemeClr val="accent1"/>
+          </a:effectRef>
+          <a:fontRef idx="minor">
+            <a:schemeClr val="lt1"/>
+          </a:fontRef>
+        </p:style>
+        <p:txBody>
+          <a:bodyPr rtlCol="0" anchor="ctr"/>
+          <a:lstStyle/>
+          <a:p>
+            <a:pPr algn="ctr"/>
+          </a:p>
+        </p:txBody>
+      </p:sp>
+      <p:sp>
+        <p:nvSpPr>
+          <p:cNvPr id="6" name="TextBox 5"/>
+          <p:cNvSpPr txBox="1"/>
+          <p:nvPr/>
+        </p:nvSpPr>
+        <p:spPr>
+          <a:xfrm>
+            <a:off x="502920" y="6473952"/>
+            <a:ext cx="10424160" cy="228600"/>
+          </a:xfrm>
+          <a:prstGeom prst="rect">
+            <a:avLst/>
+          </a:prstGeom>
+          <a:noFill/>
+        </p:spPr>
+        <p:txBody>
+          <a:bodyPr wrap="square" lIns="0" rIns="0" tIns="0" bIns="0">
+            <a:spAutoFit/>
+          </a:bodyPr>
+          <a:lstStyle/>
+          <a:p>
+            <a:pPr>
+              <a:spcAft>
+                <a:spcPts val="600"/>
+              </a:spcAft>
+              <a:defRPr sz="900" b="0">
+                <a:solidFill>
+                  <a:srgbClr val="526575"/>
+                </a:solidFill>
+                <a:latin typeface="DejaVu Sans"/>
+              </a:defRPr>
+            </a:pPr>
+            <a:r>
+              <a:t>Fonte: planilha de equiparação pela DIB e simulação em R • Valores reais: R$ de 2026</a:t>
+            </a:r>
+          </a:p>
+        </p:txBody>
+      </p:sp>
+      <p:sp>
+        <p:nvSpPr>
+          <p:cNvPr id="7" name="TextBox 6"/>
+          <p:cNvSpPr txBox="1"/>
+          <p:nvPr/>
+        </p:nvSpPr>
+        <p:spPr>
+          <a:xfrm>
+            <a:off x="11155680" y="6473952"/>
+            <a:ext cx="457200" cy="228600"/>
+          </a:xfrm>
+          <a:prstGeom prst="rect">
+            <a:avLst/>
+          </a:prstGeom>
+          <a:noFill/>
+        </p:spPr>
+        <p:txBody>
+          <a:bodyPr wrap="square" lIns="0" rIns="0" tIns="0" bIns="0">
+            <a:spAutoFit/>
+          </a:bodyPr>
+          <a:lstStyle/>
+          <a:p>
+            <a:pPr>
+              <a:spcAft>
+                <a:spcPts val="600"/>
+              </a:spcAft>
+              <a:defRPr sz="900" b="0">
+                <a:solidFill>
+                  <a:srgbClr val="526575"/>
+                </a:solidFill>
+                <a:latin typeface="DejaVu Sans"/>
+              </a:defRPr>
+            </a:pPr>
+            <a:r>
+              <a:t>5/5</a:t>
+            </a:r>
+          </a:p>
+        </p:txBody>
+      </p:sp>
+      <p:sp>
+        <p:nvSpPr>
+          <p:cNvPr id="8" name="TextBox 7"/>
+          <p:cNvSpPr txBox="1"/>
+          <p:nvPr/>
+        </p:nvSpPr>
+        <p:spPr>
+          <a:xfrm>
+            <a:off x="594360" y="1673352"/>
+            <a:ext cx="10972800" cy="411480"/>
+          </a:xfrm>
+          <a:prstGeom prst="rect">
+            <a:avLst/>
+          </a:prstGeom>
+          <a:noFill/>
+        </p:spPr>
+        <p:txBody>
+          <a:bodyPr wrap="square" lIns="0" rIns="0" tIns="0" bIns="0">
+            <a:spAutoFit/>
+          </a:bodyPr>
+          <a:lstStyle/>
+          <a:p>
+            <a:pPr>
+              <a:spcAft>
+                <a:spcPts val="600"/>
+              </a:spcAft>
+              <a:defRPr sz="1900" b="0">
+                <a:solidFill>
+                  <a:srgbClr val="526575"/>
+                </a:solidFill>
+                <a:latin typeface="DejaVu Sans"/>
+              </a:defRPr>
+            </a:pPr>
+            <a:r>
+              <a:t>Valores em R$ bilhões de 2026 • acumulados desde 2027</a:t>
+            </a:r>
+          </a:p>
+        </p:txBody>
+      </p:sp>
+      <p:graphicFrame>
+        <p:nvGraphicFramePr>
+          <p:cNvPr id="9" name="Table 8"/>
+          <p:cNvGraphicFramePr>
+            <a:graphicFrameLocks noGrp="1"/>
+          </p:cNvGraphicFramePr>
+          <p:nvPr/>
+        </p:nvGraphicFramePr>
+        <p:xfrm>
+          <a:off x="594360" y="2331720"/>
+          <a:ext cx="10424160" cy="2990088"/>
+        </p:xfrm>
+        <a:graphic>
+          <a:graphicData uri="http://schemas.openxmlformats.org/drawingml/2006/table">
+            <a:tbl>
+              <a:tblPr firstRow="1" bandRow="1">
+                <a:tableStyleId>{5C22544A-7EE6-4342-B048-85BDC9FD1C3A}</a:tableStyleId>
+              </a:tblPr>
+              <a:tblGrid>
+                <a:gridCol w="1463040"/>
+                <a:gridCol w="3429000"/>
+                <a:gridCol w="3429000"/>
+                <a:gridCol w="2103120"/>
+              </a:tblGrid>
+              <a:tr h="685800">
+                <a:tc>
+                  <a:txBody>
+                    <a:bodyPr/>
+                    <a:lstStyle/>
+                    <a:p>
+                      <a:pPr algn="l">
+                        <a:defRPr sz="1700" b="1">
+                          <a:solidFill>
+                            <a:srgbClr val="FFFFFF"/>
+                          </a:solidFill>
+                          <a:latin typeface="DejaVu Sans"/>
+                        </a:defRPr>
+                      </a:pPr>
+                      <a:r>
+                        <a:t>Até o ano</a:t>
+                      </a:r>
+                    </a:p>
+                  </a:txBody>
+                  <a:tcPr marL="146304" marR="146304" anchor="ctr">
+                    <a:solidFill>
+                      <a:srgbClr val="142D45"/>
+                    </a:solidFill>
+                  </a:tcPr>
+                </a:tc>
+                <a:tc>
+                  <a:txBody>
+                    <a:bodyPr/>
+                    <a:lstStyle/>
+                    <a:p>
+                      <a:pPr algn="r">
+                        <a:defRPr sz="1700" b="1">
+                          <a:solidFill>
+                            <a:srgbClr val="FFFFFF"/>
+                          </a:solidFill>
+                          <a:latin typeface="DejaVu Sans"/>
+                        </a:defRPr>
+                      </a:pPr>
+                      <a:r>
+                        <a:t>Aumento de idade</a:t>
+                      </a:r>
+                    </a:p>
+                  </a:txBody>
+                  <a:tcPr marL="146304" marR="146304" anchor="ctr">
+                    <a:solidFill>
+                      <a:srgbClr val="142D45"/>
+                    </a:solidFill>
+                  </a:tcPr>
+                </a:tc>
+                <a:tc>
+                  <a:txBody>
+                    <a:bodyPr/>
+                    <a:lstStyle/>
+                    <a:p>
+                      <a:pPr algn="r">
+                        <a:defRPr sz="1700" b="1">
+                          <a:solidFill>
+                            <a:srgbClr val="FFFFFF"/>
+                          </a:solidFill>
+                          <a:latin typeface="DejaVu Sans"/>
+                        </a:defRPr>
+                      </a:pPr>
+                      <a:r>
+                        <a:t>Exclusão dos 40%</a:t>
+                      </a:r>
+                    </a:p>
+                  </a:txBody>
+                  <a:tcPr marL="146304" marR="146304" anchor="ctr">
+                    <a:solidFill>
+                      <a:srgbClr val="142D45"/>
+                    </a:solidFill>
+                  </a:tcPr>
+                </a:tc>
+                <a:tc>
+                  <a:txBody>
+                    <a:bodyPr/>
+                    <a:lstStyle/>
+                    <a:p>
+                      <a:pPr algn="r">
+                        <a:defRPr sz="1700" b="1">
+                          <a:solidFill>
+                            <a:srgbClr val="FFFFFF"/>
+                          </a:solidFill>
+                          <a:latin typeface="DejaVu Sans"/>
+                        </a:defRPr>
+                      </a:pPr>
+                      <a:r>
+                        <a:t>Total</a:t>
+                      </a:r>
+                    </a:p>
+                  </a:txBody>
+                  <a:tcPr marL="146304" marR="146304" anchor="ctr">
+                    <a:solidFill>
+                      <a:srgbClr val="142D45"/>
+                    </a:solidFill>
+                  </a:tcPr>
+                </a:tc>
+              </a:tr>
+              <a:tr h="576072">
+                <a:tc>
+                  <a:txBody>
+                    <a:bodyPr/>
+                    <a:lstStyle/>
+                    <a:p>
+                      <a:pPr algn="l">
+                        <a:defRPr sz="2100" b="0">
+                          <a:solidFill>
+                            <a:srgbClr val="142D45"/>
+                          </a:solidFill>
+                          <a:latin typeface="DejaVu Sans"/>
+                        </a:defRPr>
+                      </a:pPr>
+                      <a:r>
+                        <a:t>2030</a:t>
+                      </a:r>
+                    </a:p>
+                  </a:txBody>
+                  <a:tcPr marL="146304" marR="146304" anchor="ctr">
+                    <a:solidFill>
+                      <a:srgbClr val="EDF3F5"/>
+                    </a:solidFill>
+                  </a:tcPr>
+                </a:tc>
+                <a:tc>
+                  <a:txBody>
+                    <a:bodyPr/>
+                    <a:lstStyle/>
+                    <a:p>
+                      <a:pPr algn="r">
+                        <a:defRPr sz="2100" b="0">
+                          <a:solidFill>
+                            <a:srgbClr val="142D45"/>
+                          </a:solidFill>
+                          <a:latin typeface="DejaVu Sans"/>
+                        </a:defRPr>
+                      </a:pPr>
+                      <a:r>
+                        <a:t>15,850</a:t>
+                      </a:r>
+                    </a:p>
+                  </a:txBody>
+                  <a:tcPr marL="146304" marR="146304" anchor="ctr">
+                    <a:solidFill>
+                      <a:srgbClr val="EDF3F5"/>
+                    </a:solidFill>
+                  </a:tcPr>
+                </a:tc>
+                <a:tc>
+                  <a:txBody>
+                    <a:bodyPr/>
+                    <a:lstStyle/>
+                    <a:p>
+                      <a:pPr algn="r">
+                        <a:defRPr sz="2100" b="0">
+                          <a:solidFill>
+                            <a:srgbClr val="142D45"/>
+                          </a:solidFill>
+                          <a:latin typeface="DejaVu Sans"/>
+                        </a:defRPr>
+                      </a:pPr>
+                      <a:r>
+                        <a:t>16,191</a:t>
+                      </a:r>
+                    </a:p>
+                  </a:txBody>
+                  <a:tcPr marL="146304" marR="146304" anchor="ctr">
+                    <a:solidFill>
+                      <a:srgbClr val="EDF3F5"/>
+                    </a:solidFill>
+                  </a:tcPr>
+                </a:tc>
+                <a:tc>
+                  <a:txBody>
+                    <a:bodyPr/>
+                    <a:lstStyle/>
+                    <a:p>
+                      <a:pPr algn="r">
+                        <a:defRPr sz="2100" b="1">
+                          <a:solidFill>
+                            <a:srgbClr val="FFFFFF"/>
+                          </a:solidFill>
+                          <a:latin typeface="DejaVu Sans"/>
+                        </a:defRPr>
+                      </a:pPr>
+                      <a:r>
+                        <a:t>32,041</a:t>
+                      </a:r>
+                    </a:p>
+                  </a:txBody>
+                  <a:tcPr marL="146304" marR="146304" anchor="ctr">
+                    <a:solidFill>
+                      <a:srgbClr val="008675"/>
+                    </a:solidFill>
+                  </a:tcPr>
+                </a:tc>
+              </a:tr>
+              <a:tr h="576072">
+                <a:tc>
+                  <a:txBody>
+                    <a:bodyPr/>
+                    <a:lstStyle/>
+                    <a:p>
+                      <a:pPr algn="l">
+                        <a:defRPr sz="2100" b="0">
+                          <a:solidFill>
+                            <a:srgbClr val="142D45"/>
+                          </a:solidFill>
+                          <a:latin typeface="DejaVu Sans"/>
+                        </a:defRPr>
+                      </a:pPr>
+                      <a:r>
+                        <a:t>2040</a:t>
+                      </a:r>
+                    </a:p>
+                  </a:txBody>
+                  <a:tcPr marL="146304" marR="146304" anchor="ctr">
+                    <a:solidFill>
+                      <a:srgbClr val="FFFFFF"/>
+                    </a:solidFill>
+                  </a:tcPr>
+                </a:tc>
+                <a:tc>
+                  <a:txBody>
+                    <a:bodyPr/>
+                    <a:lstStyle/>
+                    <a:p>
+                      <a:pPr algn="r">
+                        <a:defRPr sz="2100" b="0">
+                          <a:solidFill>
+                            <a:srgbClr val="142D45"/>
+                          </a:solidFill>
+                          <a:latin typeface="DejaVu Sans"/>
+                        </a:defRPr>
+                      </a:pPr>
+                      <a:r>
+                        <a:t>377,579</a:t>
+                      </a:r>
+                    </a:p>
+                  </a:txBody>
+                  <a:tcPr marL="146304" marR="146304" anchor="ctr">
+                    <a:solidFill>
+                      <a:srgbClr val="FFFFFF"/>
+                    </a:solidFill>
+                  </a:tcPr>
+                </a:tc>
+                <a:tc>
+                  <a:txBody>
+                    <a:bodyPr/>
+                    <a:lstStyle/>
+                    <a:p>
+                      <a:pPr algn="r">
+                        <a:defRPr sz="2100" b="0">
+                          <a:solidFill>
+                            <a:srgbClr val="142D45"/>
+                          </a:solidFill>
+                          <a:latin typeface="DejaVu Sans"/>
+                        </a:defRPr>
+                      </a:pPr>
+                      <a:r>
+                        <a:t>372,346</a:t>
+                      </a:r>
+                    </a:p>
+                  </a:txBody>
+                  <a:tcPr marL="146304" marR="146304" anchor="ctr">
+                    <a:solidFill>
+                      <a:srgbClr val="FFFFFF"/>
+                    </a:solidFill>
+                  </a:tcPr>
+                </a:tc>
+                <a:tc>
+                  <a:txBody>
+                    <a:bodyPr/>
+                    <a:lstStyle/>
+                    <a:p>
+                      <a:pPr algn="r">
+                        <a:defRPr sz="2100" b="1">
+                          <a:solidFill>
+                            <a:srgbClr val="FFFFFF"/>
+                          </a:solidFill>
+                          <a:latin typeface="DejaVu Sans"/>
+                        </a:defRPr>
+                      </a:pPr>
+                      <a:r>
+                        <a:t>749,925</a:t>
+                      </a:r>
+                    </a:p>
+                  </a:txBody>
+                  <a:tcPr marL="146304" marR="146304" anchor="ctr">
+                    <a:solidFill>
+                      <a:srgbClr val="008675"/>
+                    </a:solidFill>
+                  </a:tcPr>
+                </a:tc>
+              </a:tr>
+              <a:tr h="576072">
+                <a:tc>
+                  <a:txBody>
+                    <a:bodyPr/>
+                    <a:lstStyle/>
+                    <a:p>
+                      <a:pPr algn="l">
+                        <a:defRPr sz="2100" b="0">
+                          <a:solidFill>
+                            <a:srgbClr val="142D45"/>
+                          </a:solidFill>
+                          <a:latin typeface="DejaVu Sans"/>
+                        </a:defRPr>
+                      </a:pPr>
+                      <a:r>
+                        <a:t>2050</a:t>
+                      </a:r>
+                    </a:p>
+                  </a:txBody>
+                  <a:tcPr marL="146304" marR="146304" anchor="ctr">
+                    <a:solidFill>
+                      <a:srgbClr val="EDF3F5"/>
+                    </a:solidFill>
+                  </a:tcPr>
+                </a:tc>
+                <a:tc>
+                  <a:txBody>
+                    <a:bodyPr/>
+                    <a:lstStyle/>
+                    <a:p>
+                      <a:pPr algn="r">
+                        <a:defRPr sz="2100" b="0">
+                          <a:solidFill>
+                            <a:srgbClr val="142D45"/>
+                          </a:solidFill>
+                          <a:latin typeface="DejaVu Sans"/>
+                        </a:defRPr>
+                      </a:pPr>
+                      <a:r>
+                        <a:t>959,588</a:t>
+                      </a:r>
+                    </a:p>
+                  </a:txBody>
+                  <a:tcPr marL="146304" marR="146304" anchor="ctr">
+                    <a:solidFill>
+                      <a:srgbClr val="EDF3F5"/>
+                    </a:solidFill>
+                  </a:tcPr>
+                </a:tc>
+                <a:tc>
+                  <a:txBody>
+                    <a:bodyPr/>
+                    <a:lstStyle/>
+                    <a:p>
+                      <a:pPr algn="r">
+                        <a:defRPr sz="2100" b="0">
+                          <a:solidFill>
+                            <a:srgbClr val="142D45"/>
+                          </a:solidFill>
+                          <a:latin typeface="DejaVu Sans"/>
+                        </a:defRPr>
+                      </a:pPr>
+                      <a:r>
+                        <a:t>1.362,824</a:t>
+                      </a:r>
+                    </a:p>
+                  </a:txBody>
+                  <a:tcPr marL="146304" marR="146304" anchor="ctr">
+                    <a:solidFill>
+                      <a:srgbClr val="EDF3F5"/>
+                    </a:solidFill>
+                  </a:tcPr>
+                </a:tc>
+                <a:tc>
+                  <a:txBody>
+                    <a:bodyPr/>
+                    <a:lstStyle/>
+                    <a:p>
+                      <a:pPr algn="r">
+                        <a:defRPr sz="2100" b="1">
+                          <a:solidFill>
+                            <a:srgbClr val="FFFFFF"/>
+                          </a:solidFill>
+                          <a:latin typeface="DejaVu Sans"/>
+                        </a:defRPr>
+                      </a:pPr>
+                      <a:r>
+                        <a:t>2.322,413</a:t>
+                      </a:r>
+                    </a:p>
+                  </a:txBody>
+                  <a:tcPr marL="146304" marR="146304" anchor="ctr">
+                    <a:solidFill>
+                      <a:srgbClr val="008675"/>
+                    </a:solidFill>
+                  </a:tcPr>
+                </a:tc>
+              </a:tr>
+              <a:tr h="576072">
+                <a:tc>
+                  <a:txBody>
+                    <a:bodyPr/>
+                    <a:lstStyle/>
+                    <a:p>
+                      <a:pPr algn="l">
+                        <a:defRPr sz="2100" b="0">
+                          <a:solidFill>
+                            <a:srgbClr val="142D45"/>
+                          </a:solidFill>
+                          <a:latin typeface="DejaVu Sans"/>
+                        </a:defRPr>
+                      </a:pPr>
+                      <a:r>
+                        <a:t>2060</a:t>
+                      </a:r>
+                    </a:p>
+                  </a:txBody>
+                  <a:tcPr marL="146304" marR="146304" anchor="ctr">
+                    <a:solidFill>
+                      <a:srgbClr val="FFFFFF"/>
+                    </a:solidFill>
+                  </a:tcPr>
+                </a:tc>
+                <a:tc>
+                  <a:txBody>
+                    <a:bodyPr/>
+                    <a:lstStyle/>
+                    <a:p>
+                      <a:pPr algn="r">
+                        <a:defRPr sz="2100" b="0">
+                          <a:solidFill>
+                            <a:srgbClr val="142D45"/>
+                          </a:solidFill>
+                          <a:latin typeface="DejaVu Sans"/>
+                        </a:defRPr>
+                      </a:pPr>
+                      <a:r>
+                        <a:t>1.591,287</a:t>
+                      </a:r>
+                    </a:p>
+                  </a:txBody>
+                  <a:tcPr marL="146304" marR="146304" anchor="ctr">
+                    <a:solidFill>
+                      <a:srgbClr val="FFFFFF"/>
+                    </a:solidFill>
+                  </a:tcPr>
+                </a:tc>
+                <a:tc>
+                  <a:txBody>
+                    <a:bodyPr/>
+                    <a:lstStyle/>
+                    <a:p>
+                      <a:pPr algn="r">
+                        <a:defRPr sz="2100" b="0">
+                          <a:solidFill>
+                            <a:srgbClr val="142D45"/>
+                          </a:solidFill>
+                          <a:latin typeface="DejaVu Sans"/>
+                        </a:defRPr>
+                      </a:pPr>
+                      <a:r>
+                        <a:t>3.110,676</a:t>
+                      </a:r>
+                    </a:p>
+                  </a:txBody>
+                  <a:tcPr marL="146304" marR="146304" anchor="ctr">
+                    <a:solidFill>
+                      <a:srgbClr val="FFFFFF"/>
+                    </a:solidFill>
+                  </a:tcPr>
+                </a:tc>
+                <a:tc>
+                  <a:txBody>
+                    <a:bodyPr/>
+                    <a:lstStyle/>
+                    <a:p>
+                      <a:pPr algn="r">
+                        <a:defRPr sz="2100" b="1">
+                          <a:solidFill>
+                            <a:srgbClr val="FFFFFF"/>
+                          </a:solidFill>
+                          <a:latin typeface="DejaVu Sans"/>
+                        </a:defRPr>
+                      </a:pPr>
+                      <a:r>
+                        <a:t>4.701,963</a:t>
+                      </a:r>
+                    </a:p>
+                  </a:txBody>
+                  <a:tcPr marL="146304" marR="146304" anchor="ctr">
+                    <a:solidFill>
+                      <a:srgbClr val="008675"/>
+                    </a:solidFill>
+                  </a:tcPr>
+                </a:tc>
+              </a:tr>
+            </a:tbl>
+          </a:graphicData>
+        </a:graphic>
+      </p:graphicFrame>
+      <p:sp>
+        <p:nvSpPr>
+          <p:cNvPr id="10" name="TextBox 9"/>
+          <p:cNvSpPr txBox="1"/>
+          <p:nvPr/>
+        </p:nvSpPr>
+        <p:spPr>
+          <a:xfrm>
+            <a:off x="640080" y="5486400"/>
+            <a:ext cx="10881360" cy="566928"/>
+          </a:xfrm>
+          <a:prstGeom prst="rect">
+            <a:avLst/>
+          </a:prstGeom>
+          <a:noFill/>
+        </p:spPr>
+        <p:txBody>
+          <a:bodyPr wrap="square" lIns="0" rIns="0" tIns="0" bIns="0">
+            <a:spAutoFit/>
+          </a:bodyPr>
+          <a:lstStyle/>
+          <a:p>
+            <a:pPr>
+              <a:spcAft>
+                <a:spcPts val="600"/>
+              </a:spcAft>
+              <a:defRPr sz="1700" b="1">
+                <a:solidFill>
+                  <a:srgbClr val="142D45"/>
+                </a:solidFill>
+                <a:latin typeface="DejaVu Sans"/>
+              </a:defRPr>
+            </a:pPr>
+            <a:r>
+              <a:t>Total = adiamento entre os 60% elegíveis + pagamentos evitados pela exclusão dos outros 40%.</a:t>
+            </a:r>
+          </a:p>
+        </p:txBody>
+      </p:sp>
+      <p:sp>
+        <p:nvSpPr>
+          <p:cNvPr id="11" name="TextBox 10"/>
+          <p:cNvSpPr txBox="1"/>
+          <p:nvPr/>
+        </p:nvSpPr>
+        <p:spPr>
+          <a:xfrm>
+            <a:off x="640080" y="6080760"/>
+            <a:ext cx="10881360" cy="228600"/>
+          </a:xfrm>
+          <a:prstGeom prst="rect">
+            <a:avLst/>
+          </a:prstGeom>
+          <a:noFill/>
+        </p:spPr>
+        <p:txBody>
+          <a:bodyPr wrap="square" lIns="0" rIns="0" tIns="0" bIns="0">
+            <a:spAutoFit/>
+          </a:bodyPr>
+          <a:lstStyle/>
+          <a:p>
+            <a:pPr>
+              <a:spcAft>
+                <a:spcPts val="600"/>
+              </a:spcAft>
+              <a:defRPr sz="1000" b="0">
+                <a:solidFill>
+                  <a:srgbClr val="526575"/>
+                </a:solidFill>
+                <a:latin typeface="DejaVu Sans"/>
+              </a:defRPr>
+            </a:pPr>
+            <a:r>
+              <a:t>Os componentes e o total são arredondados separadamente para três casas decimais.</a:t>
             </a:r>
           </a:p>
         </p:txBody>

</xml_diff>